<commit_message>
Pitch deck: contact email to hello@mydocdesk.com
</commit_message>
<xml_diff>
--- a/MyDocDesk_Pitch_Deck.pptx
+++ b/MyDocDesk_Pitch_Deck.pptx
@@ -794,6 +794,24 @@
           <a:p>
             <a:r>
               <a:rPr lang="en-US"/>
+              <a:t>Calendar layer: confirmed bookings land on a dedicated color-coded "Anastasia AI" sub-calendar (teal badge on the phone mock), after Anastasia reads busy blocks across personal, hospital-rounds and clinic calendars without leaking private details — the same layer shown in step 4 on slide 3.</a:t>
+            </a:r>
+          </a:p>
+          <a:p>
+            <a:r>
+              <a:rPr lang="en-US"/>
+              <a:t>Zero-App quick approval: for Priority 2/3 bookings and GeSY admin requests (repeat prescriptions, referrals, lab reviews), Anastasia sends a compact WhatsApp digest — Reply [A] Approve &amp; Send, [B] Book Morning Slot, [C] Request Photo/Labs, [D] Doctor Call Back. The doctor acts in 1 second from the lock screen, no dashboard needed.</a:t>
+            </a:r>
+          </a:p>
+          <a:p>
+            <a:r>
+              <a:rPr lang="en-US"/>
+              <a:t>Source for both features: product decision approved by Christos (Oct 2026); not yet described on mydocdesk.com.</a:t>
+            </a:r>
+          </a:p>
+          <a:p>
+            <a:r>
+              <a:rPr lang="en-US"/>
               <a:t>Sources: https://mydocdesk.com ; /workspace/mydocdesk/index.html, app.js, leave-behind.html.</a:t>
             </a:r>
           </a:p>
@@ -881,13 +899,31 @@
           <a:p>
             <a:r>
               <a:rPr lang="en-US"/>
-              <a:t>Meet Sofia, the 24/7 AI medical &amp; dental receptionist.</a:t>
+              <a:t>Meet Anastasia, the 24/7 AI medical &amp; dental receptionist.</a:t>
             </a:r>
           </a:p>
           <a:p>
             <a:r>
               <a:rPr lang="en-US"/>
-              <a:t>Sources: https://mydocdesk.com ; /workspace/mydocdesk/index.html (How Sofia Works: Cyta/Epic/Cablenet, *67*/*61* forwarding, EL/EN/RU, WhatsApp/SMS), app.js.</a:t>
+              <a:t>Step 4 — Smart Calendar &amp; Case Note: Anastasia reads busy blocks across all of the doctor's connected calendars (personal, hospital rounds, clinic) without exposing private event details, then books confirmed appointments onto a dedicated color-coded "Anastasia AI" Google Calendar sub-calendar, so AI-booked vs. manual slots are visible at a glance.</a:t>
+            </a:r>
+          </a:p>
+          <a:p>
+            <a:r>
+              <a:rPr lang="en-US"/>
+              <a:t>Every booking also triggers the Zero-App WhatsApp quick-approval flow on slide 5 (Reply A / B / C / D) for Priority 2/3 and GeSY admin requests.</a:t>
+            </a:r>
+          </a:p>
+          <a:p>
+            <a:r>
+              <a:rPr lang="en-US"/>
+              <a:t>Source for the calendar layer and A/B/C/D approval features: product decision approved by Christos (Oct 2026).</a:t>
+            </a:r>
+          </a:p>
+          <a:p>
+            <a:r>
+              <a:rPr lang="en-US"/>
+              <a:t>Sources: https://mydocdesk.com ; /workspace/mydocdesk/index.html (How Anastasia Works: Cyta/Epic/Cablenet, *67*/*61* forwarding, EL/EN/RU, WhatsApp/SMS), app.js.</a:t>
             </a:r>
           </a:p>
         </p:txBody>
@@ -980,7 +1016,7 @@
           <a:p>
             <a:r>
               <a:rPr lang="en-US"/>
-              <a:t>Contact: Christos Taliadoros, christos@t-knights.com, +357 99 429249. Attribution confirmed by Christos: Engineered &amp; Supported by T-Knights Consulting Ltd (Cyprus).</a:t>
+              <a:t>Contact: Christos Taliadoros, hello@mydocdesk.com, +357 99 429249. Attribution confirmed by Christos: Engineered &amp; Supported by T-Knights Consulting Ltd (Cyprus).</a:t>
             </a:r>
           </a:p>
           <a:p>
@@ -2234,7 +2270,7 @@
                 <a:ea typeface="DM Sans" pitchFamily="34" charset="-122"/>
                 <a:cs typeface="DM Sans" pitchFamily="34" charset="-120"/>
               </a:rPr>
-              <a:t>High pediatric fever (&gt;39°C), acute otalgia, broken front crown, or severe toothache → Sofia screens red flags and unlocks your protected 12:30 PM / 5:00 PM Emergency Buffer Slot.</a:t>
+              <a:t>High pediatric fever (&gt;39°C), acute otalgia, broken front crown, or severe toothache → Anastasia screens red flags and unlocks your protected 12:30 PM / 5:00 PM Emergency Buffer Slot.</a:t>
             </a:r>
             <a:endParaRPr lang="en-US" sz="950" dirty="0"/>
           </a:p>
@@ -2354,7 +2390,7 @@
                 <a:ea typeface="DM Sans" pitchFamily="34" charset="-122"/>
                 <a:cs typeface="DM Sans" pitchFamily="34" charset="-120"/>
               </a:rPr>
-              <a:t>Spreading skin rash, lab review, lost filling, or implant consult → Sofia requests a smartphone photo or PDF on WhatsApp and books the right slot duration (15m / 30m / 45m / 60m).</a:t>
+              <a:t>Spreading skin rash, lab review, lost filling, or implant consult → Anastasia requests a smartphone photo or PDF on WhatsApp and books the right slot duration (15m / 30m / 45m / 60m).</a:t>
             </a:r>
             <a:endParaRPr lang="en-US" sz="950" dirty="0"/>
           </a:p>
@@ -4038,7 +4074,7 @@
         </p:nvSpPr>
         <p:spPr>
           <a:xfrm>
-            <a:off x="440740" y="548640"/>
+            <a:off x="440740" y="502920"/>
             <a:ext cx="4572000" cy="868680"/>
           </a:xfrm>
           <a:prstGeom prst="rect">
@@ -4134,7 +4170,29 @@
                 <a:ea typeface="Lexend"/>
                 <a:cs typeface="Lexend"/>
               </a:rPr>
-              <a:t>TODAY  •  Google / Apple / Outlook</a:t>
+              <a:t>TODAY  •  </a:t>
+            </a:r>
+            <a:r>
+              <a:rPr lang="en-US" sz="900" b="1" dirty="0">
+                <a:solidFill>
+                  <a:srgbClr val="14B8A6"/>
+                </a:solidFill>
+                <a:latin typeface="Lexend"/>
+                <a:ea typeface="Lexend"/>
+                <a:cs typeface="Lexend"/>
+              </a:rPr>
+              <a:t>■ </a:t>
+            </a:r>
+            <a:r>
+              <a:rPr lang="en-US" sz="900" b="1" dirty="0">
+                <a:solidFill>
+                  <a:srgbClr val="0F766E"/>
+                </a:solidFill>
+                <a:latin typeface="Lexend"/>
+                <a:ea typeface="Lexend"/>
+                <a:cs typeface="Lexend"/>
+              </a:rPr>
+              <a:t>Anastasia AI layer</a:t>
             </a:r>
           </a:p>
         </p:txBody>
@@ -4376,6 +4434,95 @@
       </p:sp>
       <p:sp>
         <p:nvSpPr>
+          <p:cNvPr id="28" name="WhatsApp Digest"/>
+          <p:cNvSpPr/>
+          <p:nvPr/>
+        </p:nvSpPr>
+        <p:spPr>
+          <a:xfrm>
+            <a:off x="5074920" y="502920"/>
+            <a:ext cx="3611880" cy="749808"/>
+          </a:xfrm>
+          <a:prstGeom prst="roundRect">
+            <a:avLst>
+              <a:gd name="adj" fmla="val 8000"/>
+            </a:avLst>
+          </a:prstGeom>
+          <a:solidFill>
+            <a:srgbClr val="0A192F"/>
+          </a:solidFill>
+          <a:ln w="9525">
+            <a:solidFill>
+              <a:srgbClr val="0A192F"/>
+            </a:solidFill>
+          </a:ln>
+        </p:spPr>
+        <p:txBody>
+          <a:bodyPr wrap="square" lIns="109728" tIns="45720" rIns="109728" bIns="45720" anchor="t" rtlCol="0">
+            <a:noAutofit/>
+          </a:bodyPr>
+          <a:lstStyle/>
+          <a:p>
+            <a:pPr algn="l">
+              <a:lnSpc>
+                <a:spcPct val="110000"/>
+              </a:lnSpc>
+              <a:buNone/>
+            </a:pPr>
+            <a:r>
+              <a:rPr lang="en-US" sz="850" b="1" dirty="0">
+                <a:solidFill>
+                  <a:srgbClr val="FFFFFF"/>
+                </a:solidFill>
+                <a:latin typeface="Lexend"/>
+                <a:ea typeface="Lexend"/>
+                <a:cs typeface="Lexend"/>
+              </a:rPr>
+              <a:t>WhatsApp · P2 GeSY repeat script — Reply A / B / C / D</a:t>
+            </a:r>
+          </a:p>
+          <a:p>
+            <a:pPr algn="l">
+              <a:lnSpc>
+                <a:spcPct val="110000"/>
+              </a:lnSpc>
+              <a:buNone/>
+            </a:pPr>
+            <a:r>
+              <a:rPr lang="en-US" sz="900" b="1" dirty="0">
+                <a:solidFill>
+                  <a:srgbClr val="5EEAD4"/>
+                </a:solidFill>
+                <a:latin typeface="DM Sans"/>
+                <a:ea typeface="DM Sans"/>
+                <a:cs typeface="DM Sans"/>
+              </a:rPr>
+              <a:t>[A] Approve &amp; Send     [B] Book Morning Slot</a:t>
+            </a:r>
+          </a:p>
+          <a:p>
+            <a:pPr algn="l">
+              <a:lnSpc>
+                <a:spcPct val="110000"/>
+              </a:lnSpc>
+              <a:buNone/>
+            </a:pPr>
+            <a:r>
+              <a:rPr lang="en-US" sz="900" b="1" dirty="0">
+                <a:solidFill>
+                  <a:srgbClr val="5EEAD4"/>
+                </a:solidFill>
+                <a:latin typeface="DM Sans"/>
+                <a:ea typeface="DM Sans"/>
+                <a:cs typeface="DM Sans"/>
+              </a:rPr>
+              <a:t>[C] Request Photo/Labs     [D] Doctor Call Back</a:t>
+            </a:r>
+          </a:p>
+        </p:txBody>
+      </p:sp>
+      <p:sp>
+        <p:nvSpPr>
           <p:cNvPr id="13" name="Shape 10"/>
           <p:cNvSpPr/>
           <p:nvPr/>
@@ -4407,8 +4554,8 @@
         </p:nvSpPr>
         <p:spPr>
           <a:xfrm>
-            <a:off x="440740" y="1600200"/>
-            <a:ext cx="4160520" cy="274320"/>
+            <a:off x="440740" y="1444752"/>
+            <a:ext cx="4160520" cy="256032"/>
           </a:xfrm>
           <a:prstGeom prst="rect">
             <a:avLst/>
@@ -4432,7 +4579,7 @@
                 <a:ea typeface="Lexend" pitchFamily="34" charset="-122"/>
                 <a:cs typeface="Lexend" pitchFamily="34" charset="-120"/>
               </a:rPr>
-              <a:t>Synced to Google, Apple &amp; Outlook Calendar</a:t>
+              <a:t>Dedicated “Anastasia AI” Calendar Layer</a:t>
             </a:r>
             <a:endParaRPr lang="en-US" sz="1250" dirty="0"/>
           </a:p>
@@ -4446,8 +4593,8 @@
         </p:nvSpPr>
         <p:spPr>
           <a:xfrm>
-            <a:off x="440740" y="1874519"/>
-            <a:ext cx="4114800" cy="777240"/>
+            <a:off x="440740" y="1691640"/>
+            <a:ext cx="4114800" cy="603504"/>
           </a:xfrm>
           <a:prstGeom prst="rect">
             <a:avLst/>
@@ -4474,7 +4621,7 @@
                 <a:ea typeface="DM Sans" pitchFamily="34" charset="-122"/>
                 <a:cs typeface="DM Sans" pitchFamily="34" charset="-120"/>
               </a:rPr>
-              <a:t>Before the patient walks into the exam room or sits in the dental chair, the doctor sees a color-coded calendar card (Case #MD-409 / #MD-415).</a:t>
+              <a:t>Reads busy blocks across personal, hospital-rounds and clinic calendars (no private details shared) and books onto a color-coded sub-calendar, so AI-booked vs. manual slots stand out.</a:t>
             </a:r>
             <a:endParaRPr lang="en-US" sz="1000" dirty="0"/>
           </a:p>
@@ -4488,8 +4635,8 @@
         </p:nvSpPr>
         <p:spPr>
           <a:xfrm>
-            <a:off x="440740" y="2651760"/>
-            <a:ext cx="4160520" cy="274320"/>
+            <a:off x="440740" y="2331720"/>
+            <a:ext cx="4160520" cy="256032"/>
           </a:xfrm>
           <a:prstGeom prst="rect">
             <a:avLst/>
@@ -4527,8 +4674,8 @@
         </p:nvSpPr>
         <p:spPr>
           <a:xfrm>
-            <a:off x="440740" y="2926079"/>
-            <a:ext cx="4114800" cy="777240"/>
+            <a:off x="440740" y="2578608"/>
+            <a:ext cx="4114800" cy="603504"/>
           </a:xfrm>
           <a:prstGeom prst="rect">
             <a:avLst/>
@@ -4555,7 +4702,7 @@
                 <a:ea typeface="DM Sans" pitchFamily="34" charset="-122"/>
                 <a:cs typeface="DM Sans" pitchFamily="34" charset="-120"/>
               </a:rPr>
-              <a:t>Chief complaint &amp; duration, medication/thermal sensitivity history, and a completed red-flag safety screen (112 / A&amp;E auto-deflection for chest pain or breathing distress).</a:t>
+              <a:t>Chief complaint &amp; duration, medication/sensitivity history, and a completed red-flag screen (112 / A&amp;E auto-deflection for chest pain or breathing distress).</a:t>
             </a:r>
             <a:endParaRPr lang="en-US" sz="1000" dirty="0"/>
           </a:p>
@@ -4569,8 +4716,8 @@
         </p:nvSpPr>
         <p:spPr>
           <a:xfrm>
-            <a:off x="440740" y="3703320"/>
-            <a:ext cx="4160520" cy="274320"/>
+            <a:off x="440740" y="3218687"/>
+            <a:ext cx="4160520" cy="256032"/>
           </a:xfrm>
           <a:prstGeom prst="rect">
             <a:avLst/>
@@ -4594,6 +4741,45 @@
                 <a:ea typeface="Lexend" pitchFamily="34" charset="-122"/>
                 <a:cs typeface="Lexend" pitchFamily="34" charset="-120"/>
               </a:rPr>
+              <a:t>Zero-App “Reply A / B / C / D” Approval</a:t>
+            </a:r>
+            <a:endParaRPr lang="en-US" sz="1250" dirty="0"/>
+          </a:p>
+        </p:txBody>
+      </p:sp>
+      <p:sp>
+        <p:nvSpPr>
+          <p:cNvPr id="26" name="Point 4 head"/>
+          <p:cNvSpPr/>
+          <p:nvPr/>
+        </p:nvSpPr>
+        <p:spPr>
+          <a:xfrm>
+            <a:off x="440740" y="4105655"/>
+            <a:ext cx="4160520" cy="256032"/>
+          </a:xfrm>
+          <a:prstGeom prst="rect">
+            <a:avLst/>
+          </a:prstGeom>
+          <a:noFill/>
+          <a:ln/>
+        </p:spPr>
+        <p:txBody>
+          <a:bodyPr wrap="square" lIns="68580" tIns="34290" rIns="68580" bIns="34290" rtlCol="0" anchor="t"/>
+          <a:lstStyle/>
+          <a:p>
+            <a:pPr indent="0" marL="0">
+              <a:buNone/>
+            </a:pPr>
+            <a:r>
+              <a:rPr lang="en-US" sz="1250" dirty="0" b="1">
+                <a:solidFill>
+                  <a:srgbClr val="0A192F"/>
+                </a:solidFill>
+                <a:latin typeface="Lexend" pitchFamily="34" charset="0"/>
+                <a:ea typeface="Lexend" pitchFamily="34" charset="-122"/>
+                <a:cs typeface="Lexend" pitchFamily="34" charset="-120"/>
+              </a:rPr>
               <a:t>Pre-Attached Photos &amp; Nurse Tray Prep</a:t>
             </a:r>
             <a:endParaRPr lang="en-US" sz="1250" dirty="0"/>
@@ -4602,14 +4788,14 @@
       </p:sp>
       <p:sp>
         <p:nvSpPr>
-          <p:cNvPr id="22" name="Point 3 body"/>
-          <p:cNvSpPr/>
-          <p:nvPr/>
-        </p:nvSpPr>
-        <p:spPr>
-          <a:xfrm>
-            <a:off x="440740" y="3977639"/>
-            <a:ext cx="4114800" cy="777240"/>
+          <p:cNvPr id="27" name="Point 4 body"/>
+          <p:cNvSpPr/>
+          <p:nvPr/>
+        </p:nvSpPr>
+        <p:spPr>
+          <a:xfrm>
+            <a:off x="440740" y="4352544"/>
+            <a:ext cx="4114800" cy="603504"/>
           </a:xfrm>
           <a:prstGeom prst="rect">
             <a:avLst/>
@@ -4636,7 +4822,49 @@
                 <a:ea typeface="DM Sans" pitchFamily="34" charset="-122"/>
                 <a:cs typeface="DM Sans" pitchFamily="34" charset="-120"/>
               </a:rPr>
-              <a:t>Patient-uploaded WhatsApp photos (skin rash, thermometer, fractured tooth #14) are linked directly to the event, along with chairside tray prep instructions for the nurse.</a:t>
+              <a:t>Patient WhatsApp photos (rash, thermometer, fractured tooth #14) and chairside tray-prep notes are linked directly to the event.</a:t>
+            </a:r>
+            <a:endParaRPr lang="en-US" sz="1000" dirty="0"/>
+          </a:p>
+        </p:txBody>
+      </p:sp>
+      <p:sp>
+        <p:nvSpPr>
+          <p:cNvPr id="22" name="Point 3 body"/>
+          <p:cNvSpPr/>
+          <p:nvPr/>
+        </p:nvSpPr>
+        <p:spPr>
+          <a:xfrm>
+            <a:off x="440740" y="3465575"/>
+            <a:ext cx="4114800" cy="603504"/>
+          </a:xfrm>
+          <a:prstGeom prst="rect">
+            <a:avLst/>
+          </a:prstGeom>
+          <a:noFill/>
+          <a:ln/>
+        </p:spPr>
+        <p:txBody>
+          <a:bodyPr wrap="square" lIns="68580" tIns="34290" rIns="68580" bIns="34290" rtlCol="0" anchor="t"/>
+          <a:lstStyle/>
+          <a:p>
+            <a:pPr indent="0" marL="0">
+              <a:lnSpc>
+                <a:spcPct val="120000"/>
+              </a:lnSpc>
+              <a:buNone/>
+            </a:pPr>
+            <a:r>
+              <a:rPr lang="en-US" sz="1000" dirty="0">
+                <a:solidFill>
+                  <a:srgbClr val="3F3F3F"/>
+                </a:solidFill>
+                <a:latin typeface="DM Sans" pitchFamily="34" charset="0"/>
+                <a:ea typeface="DM Sans" pitchFamily="34" charset="-122"/>
+                <a:cs typeface="DM Sans" pitchFamily="34" charset="-120"/>
+              </a:rPr>
+              <a:t>Priority 2/3 bookings and GeSY admin (repeat prescriptions, referrals, lab reviews) arrive as a WhatsApp digest the doctor answers in 1 second from the lock screen.</a:t>
             </a:r>
             <a:endParaRPr lang="en-US" sz="1000" dirty="0"/>
           </a:p>
@@ -4810,7 +5038,7 @@
               <a:buNone/>
             </a:pPr>
             <a:r>
-              <a:rPr lang="en-US" sz="2600" dirty="0">
+              <a:rPr lang="en-US" sz="2300" dirty="0">
                 <a:solidFill>
                   <a:srgbClr val="0A192F"/>
                 </a:solidFill>
@@ -4818,9 +5046,9 @@
                 <a:ea typeface="Lexend" pitchFamily="34" charset="-122"/>
                 <a:cs typeface="Lexend" pitchFamily="34" charset="-120"/>
               </a:rPr>
-              <a:t>Meet Sofia — Answers Every Call &amp; WhatsApp in Under 1 Second</a:t>
-            </a:r>
-            <a:endParaRPr lang="en-US" sz="2600" dirty="0"/>
+              <a:t>Meet Anastasia — Answers Every Call &amp; WhatsApp in Under 1 Second</a:t>
+            </a:r>
+            <a:endParaRPr lang="en-US" sz="2300" dirty="0"/>
           </a:p>
         </p:txBody>
       </p:sp>
@@ -5142,8 +5370,8 @@
         </p:nvSpPr>
         <p:spPr>
           <a:xfrm>
-            <a:off x="5303520" y="1143000"/>
-            <a:ext cx="3108960" cy="777240"/>
+            <a:off x="5303520" y="1097280"/>
+            <a:ext cx="3108960" cy="585216"/>
           </a:xfrm>
           <a:prstGeom prst="roundRect">
             <a:avLst>
@@ -5212,8 +5440,8 @@
         </p:nvSpPr>
         <p:spPr>
           <a:xfrm>
-            <a:off x="6720840" y="1965960"/>
-            <a:ext cx="274320" cy="228600"/>
+            <a:off x="6757416" y="1719072"/>
+            <a:ext cx="201168" cy="146304"/>
           </a:xfrm>
           <a:prstGeom prst="downArrow">
             <a:avLst/>
@@ -5243,8 +5471,8 @@
         </p:nvSpPr>
         <p:spPr>
           <a:xfrm>
-            <a:off x="5303520" y="2240280"/>
-            <a:ext cx="3108960" cy="777240"/>
+            <a:off x="5303520" y="1901952"/>
+            <a:ext cx="3108960" cy="585216"/>
           </a:xfrm>
           <a:prstGeom prst="roundRect">
             <a:avLst>
@@ -5279,7 +5507,7 @@
                 <a:ea typeface="Lexend"/>
                 <a:cs typeface="Lexend"/>
               </a:rPr>
-              <a:t>2 · Sofia answers in under 1 second</a:t>
+              <a:t>2 · Anastasia answers in under 1 sec</a:t>
             </a:r>
           </a:p>
           <a:p>
@@ -5311,8 +5539,8 @@
         </p:nvSpPr>
         <p:spPr>
           <a:xfrm>
-            <a:off x="6720840" y="3063240"/>
-            <a:ext cx="274320" cy="228600"/>
+            <a:off x="6757416" y="2523744"/>
+            <a:ext cx="201168" cy="146304"/>
           </a:xfrm>
           <a:prstGeom prst="downArrow">
             <a:avLst/>
@@ -5336,14 +5564,115 @@
       </p:sp>
       <p:sp>
         <p:nvSpPr>
+          <p:cNvPr id="22" name="G1 Arrow 4"/>
+          <p:cNvSpPr/>
+          <p:nvPr/>
+        </p:nvSpPr>
+        <p:spPr>
+          <a:xfrm>
+            <a:off x="6757416" y="3328416"/>
+            <a:ext cx="201168" cy="146304"/>
+          </a:xfrm>
+          <a:prstGeom prst="downArrow">
+            <a:avLst/>
+          </a:prstGeom>
+          <a:solidFill>
+            <a:srgbClr val="F59E0B"/>
+          </a:solidFill>
+          <a:ln>
+            <a:noFill/>
+          </a:ln>
+        </p:spPr>
+        <p:txBody>
+          <a:bodyPr wrap="square" lIns="109728" tIns="45720" rIns="109728" bIns="45720" anchor="ctr" rtlCol="0">
+            <a:noAutofit/>
+          </a:bodyPr>
+          <a:lstStyle/>
+          <a:p>
+            <a:endParaRPr lang="en-US"/>
+          </a:p>
+        </p:txBody>
+      </p:sp>
+      <p:sp>
+        <p:nvSpPr>
+          <p:cNvPr id="23" name="G1 Step 4"/>
+          <p:cNvSpPr/>
+          <p:nvPr/>
+        </p:nvSpPr>
+        <p:spPr>
+          <a:xfrm>
+            <a:off x="5303520" y="3511296"/>
+            <a:ext cx="3108960" cy="731520"/>
+          </a:xfrm>
+          <a:prstGeom prst="roundRect">
+            <a:avLst>
+              <a:gd name="adj" fmla="val 12000"/>
+            </a:avLst>
+          </a:prstGeom>
+          <a:solidFill>
+            <a:srgbClr val="FFFFFF"/>
+          </a:solidFill>
+          <a:ln w="19050">
+            <a:solidFill>
+              <a:srgbClr val="0F766E"/>
+            </a:solidFill>
+          </a:ln>
+        </p:spPr>
+        <p:txBody>
+          <a:bodyPr wrap="square" lIns="164592" tIns="45720" rIns="164592" bIns="45720" anchor="ctr" rtlCol="0">
+            <a:noAutofit/>
+          </a:bodyPr>
+          <a:lstStyle/>
+          <a:p>
+            <a:pPr algn="l">
+              <a:lnSpc>
+                <a:spcPct val="110000"/>
+              </a:lnSpc>
+              <a:buNone/>
+            </a:pPr>
+            <a:r>
+              <a:rPr lang="en-US" sz="1100" b="1" dirty="0">
+                <a:solidFill>
+                  <a:srgbClr val="0A192F"/>
+                </a:solidFill>
+                <a:latin typeface="Lexend"/>
+                <a:ea typeface="Lexend"/>
+                <a:cs typeface="Lexend"/>
+              </a:rPr>
+              <a:t>4 · Smart Calendar &amp; Case Note</a:t>
+            </a:r>
+          </a:p>
+          <a:p>
+            <a:pPr algn="l">
+              <a:lnSpc>
+                <a:spcPct val="110000"/>
+              </a:lnSpc>
+              <a:buNone/>
+            </a:pPr>
+            <a:r>
+              <a:rPr lang="en-US" sz="1000" b="0" dirty="0">
+                <a:solidFill>
+                  <a:srgbClr val="3F3F3F"/>
+                </a:solidFill>
+                <a:latin typeface="DM Sans"/>
+                <a:ea typeface="DM Sans"/>
+                <a:cs typeface="DM Sans"/>
+              </a:rPr>
+              <a:t>Reads busy blocks on all calendars, books into a color-coded “Anastasia AI” layer</a:t>
+            </a:r>
+          </a:p>
+        </p:txBody>
+      </p:sp>
+      <p:sp>
+        <p:nvSpPr>
           <p:cNvPr id="20" name="G1 20"/>
           <p:cNvSpPr/>
           <p:nvPr/>
         </p:nvSpPr>
         <p:spPr>
           <a:xfrm>
-            <a:off x="5303520" y="3337560"/>
-            <a:ext cx="3108960" cy="777240"/>
+            <a:off x="5303520" y="2706624"/>
+            <a:ext cx="3108960" cy="585216"/>
           </a:xfrm>
           <a:prstGeom prst="roundRect">
             <a:avLst>
@@ -5397,7 +5726,7 @@
                 <a:ea typeface="DM Sans"/>
                 <a:cs typeface="DM Sans"/>
               </a:rPr>
-              <a:t>Appointment pass + optional photo/lab upload link</a:t>
+              <a:t>Appointment pass + photo/lab upload link</a:t>
             </a:r>
           </a:p>
         </p:txBody>
@@ -5410,8 +5739,8 @@
         </p:nvSpPr>
         <p:spPr>
           <a:xfrm>
-            <a:off x="5303520" y="4224528"/>
-            <a:ext cx="3108960" cy="320040"/>
+            <a:off x="5303520" y="4279392"/>
+            <a:ext cx="3108960" cy="274320"/>
           </a:xfrm>
           <a:prstGeom prst="rect">
             <a:avLst/>
@@ -5442,7 +5771,7 @@
                 <a:ea typeface="DM Sans"/>
                 <a:cs typeface="DM Sans"/>
               </a:rPr>
-              <a:t>No new hardware  •  No number change</a:t>
+              <a:t>Private details never shared  •  No new hardware</a:t>
             </a:r>
           </a:p>
         </p:txBody>
@@ -6273,7 +6602,7 @@
                 <a:ea typeface="Lexend" pitchFamily="34" charset="-122"/>
                 <a:cs typeface="Lexend" pitchFamily="34" charset="-120"/>
               </a:rPr>
-              <a:t>christos@t-knights.com</a:t>
+              <a:t>hello@mydocdesk.com</a:t>
             </a:r>
             <a:endParaRPr lang="en-US" sz="1050" dirty="0"/>
           </a:p>

</xml_diff>

<commit_message>
Pitch deck: keep phone mock-up and panels inside slide bounds
</commit_message>
<xml_diff>
--- a/MyDocDesk_Pitch_Deck.pptx
+++ b/MyDocDesk_Pitch_Deck.pptx
@@ -3123,8 +3123,8 @@
         </p:nvSpPr>
         <p:spPr>
           <a:xfrm rot="5400000">
-            <a:off x="-1069848" y="1057961"/>
-            <a:ext cx="5155387" cy="3015691"/>
+            <a:off x="-1063905" y="1057961"/>
+            <a:ext cx="5143500" cy="3015691"/>
           </a:xfrm>
           <a:custGeom>
             <a:avLst/>
@@ -4116,8 +4116,8 @@
         </p:nvSpPr>
         <p:spPr>
           <a:xfrm rot="-540000">
-            <a:off x="5095037" y="1831543"/>
-            <a:ext cx="3364992" cy="5047488"/>
+            <a:off x="4936046" y="1844056"/>
+            <a:ext cx="3364992" cy="3014802"/>
           </a:xfrm>
           <a:prstGeom prst="roundRect">
             <a:avLst>
@@ -4205,8 +4205,8 @@
         </p:nvSpPr>
         <p:spPr>
           <a:xfrm rot="-540000">
-            <a:off x="5185164" y="2312230"/>
-            <a:ext cx="2743200" cy="1298448"/>
+            <a:off x="5155563" y="2314560"/>
+            <a:ext cx="2743200" cy="920000"/>
           </a:xfrm>
           <a:prstGeom prst="roundRect">
             <a:avLst>
@@ -4332,8 +4332,8 @@
         </p:nvSpPr>
         <p:spPr>
           <a:xfrm rot="-540000">
-            <a:off x="5394008" y="3731402"/>
-            <a:ext cx="2743200" cy="1097280"/>
+            <a:off x="5306860" y="3359813"/>
+            <a:ext cx="2743200" cy="740000"/>
           </a:xfrm>
           <a:prstGeom prst="roundRect">
             <a:avLst>
@@ -4529,8 +4529,8 @@
         </p:nvSpPr>
         <p:spPr>
           <a:xfrm rot="-552000">
-            <a:off x="5067605" y="1790395"/>
-            <a:ext cx="3414370" cy="5106924"/>
+            <a:off x="4904513" y="1803517"/>
+            <a:ext cx="3414370" cy="3066761"/>
           </a:xfrm>
           <a:prstGeom prst="roundRect">
             <a:avLst>

</xml_diff>